<commit_message>
Created Lahore AQI Predictor Slides
</commit_message>
<xml_diff>
--- a/Lahore_AQI_Predictor.pptx
+++ b/Lahore_AQI_Predictor.pptx
@@ -304,10 +304,10 @@
               <c:strCache>
                 <c:ptCount val="7"/>
                 <c:pt idx="0">
-                  <c:v>Extra Trees ★</c:v>
+                  <c:v>XGBRegressor</c:v>
                 </c:pt>
                 <c:pt idx="1">
-                  <c:v>XGBRegressor</c:v>
+                  <c:v>Extra Trees</c:v>
                 </c:pt>
                 <c:pt idx="2">
                   <c:v>Random Forest</c:v>
@@ -334,7 +334,7 @@
                 <c:formatCode>General</c:formatCode>
                 <c:ptCount val="7"/>
                 <c:pt idx="0">
-                  <c:v>0.93700000000000006</c:v>
+                  <c:v>0.93799999999999994</c:v>
                 </c:pt>
                 <c:pt idx="1">
                   <c:v>0.93600000000000005</c:v>
@@ -3663,29 +3663,7 @@
                 <a:ea typeface="Calibri" pitchFamily="34" charset="-122"/>
                 <a:cs typeface="Calibri" pitchFamily="34" charset="-120"/>
               </a:rPr>
-              <a:t>Seven regressors trained daily: Random Forest, Ridge, Gradient Boosting, Extra Trees, KNN, </a:t>
-            </a:r>
-            <a:r>
-              <a:rPr lang="en-US" sz="1000" dirty="0" err="1">
-                <a:solidFill>
-                  <a:srgbClr val="D8E2F5"/>
-                </a:solidFill>
-                <a:latin typeface="Calibri" pitchFamily="34" charset="0"/>
-                <a:ea typeface="Calibri" pitchFamily="34" charset="-122"/>
-                <a:cs typeface="Calibri" pitchFamily="34" charset="-120"/>
-              </a:rPr>
-              <a:t>XGBoost</a:t>
-            </a:r>
-            <a:r>
-              <a:rPr lang="en-US" sz="1000" dirty="0">
-                <a:solidFill>
-                  <a:srgbClr val="D8E2F5"/>
-                </a:solidFill>
-                <a:latin typeface="Calibri" pitchFamily="34" charset="0"/>
-                <a:ea typeface="Calibri" pitchFamily="34" charset="-122"/>
-                <a:cs typeface="Calibri" pitchFamily="34" charset="-120"/>
-              </a:rPr>
-              <a:t> and CatBoost. Best R² model auto-selected.</a:t>
+              <a:t>Seven regressors trained daily: Random Forest, Ridge, Gradient Boosting, Extra Trees, KNN, XGBoost and CatBoost. Best R² model auto-selected.</a:t>
             </a:r>
             <a:endParaRPr lang="en-US" sz="1000" dirty="0"/>
           </a:p>
@@ -5054,17 +5032,6 @@
               <a:buNone/>
             </a:pPr>
             <a:r>
-              <a:rPr lang="en-US" sz="1100" dirty="0" err="1">
-                <a:solidFill>
-                  <a:srgbClr val="FFFFFF"/>
-                </a:solidFill>
-                <a:latin typeface="Calibri" pitchFamily="34" charset="0"/>
-                <a:ea typeface="Calibri" pitchFamily="34" charset="-122"/>
-                <a:cs typeface="Calibri" pitchFamily="34" charset="-120"/>
-              </a:rPr>
-              <a:t>Streamlit</a:t>
-            </a:r>
-            <a:r>
               <a:rPr lang="en-US" sz="1100" dirty="0">
                 <a:solidFill>
                   <a:srgbClr val="FFFFFF"/>
@@ -5073,7 +5040,7 @@
                 <a:ea typeface="Calibri" pitchFamily="34" charset="-122"/>
                 <a:cs typeface="Calibri" pitchFamily="34" charset="-120"/>
               </a:rPr>
-              <a:t> Dashboard</a:t>
+              <a:t>Streamlit Dashboard</a:t>
             </a:r>
             <a:endParaRPr lang="en-US" sz="1100" dirty="0"/>
           </a:p>
@@ -6385,7 +6352,7 @@
           <p:nvPr>
             <p:extLst>
               <p:ext uri="{D42A27DB-BD31-4B8C-83A1-F6EECF244321}">
-                <p14:modId xmlns:p14="http://schemas.microsoft.com/office/powerpoint/2010/main" val="347841342"/>
+                <p14:modId xmlns:p14="http://schemas.microsoft.com/office/powerpoint/2010/main" val="96332822"/>
               </p:ext>
             </p:extLst>
           </p:nvPr>
@@ -6409,7 +6376,7 @@
           <p:nvPr>
             <p:extLst>
               <p:ext uri="{D42A27DB-BD31-4B8C-83A1-F6EECF244321}">
-                <p14:modId xmlns:p14="http://schemas.microsoft.com/office/powerpoint/2010/main" val="2450705199"/>
+                <p14:modId xmlns:p14="http://schemas.microsoft.com/office/powerpoint/2010/main" val="568048144"/>
               </p:ext>
             </p:extLst>
           </p:nvPr>
@@ -6838,8 +6805,22 @@
                     <a:bodyPr/>
                     <a:lstStyle/>
                     <a:p>
-                      <a:pPr marL="0" indent="0">
+                      <a:pPr marL="0" marR="0" lvl="0" indent="0" algn="l" defTabSz="914400" rtl="0" eaLnBrk="1" fontAlgn="auto" latinLnBrk="0" hangingPunct="1">
+                        <a:lnSpc>
+                          <a:spcPct val="100000"/>
+                        </a:lnSpc>
+                        <a:spcBef>
+                          <a:spcPts val="0"/>
+                        </a:spcBef>
+                        <a:spcAft>
+                          <a:spcPts val="0"/>
+                        </a:spcAft>
+                        <a:buClrTx/>
+                        <a:buSzTx/>
+                        <a:buFontTx/>
                         <a:buNone/>
+                        <a:tabLst/>
+                        <a:defRPr/>
                       </a:pPr>
                       <a:r>
                         <a:rPr lang="en-US" sz="1000" b="1" dirty="0">
@@ -6847,7 +6828,7 @@
                             <a:srgbClr val="00C9A7"/>
                           </a:solidFill>
                         </a:rPr>
-                        <a:t>Extra Trees</a:t>
+                        <a:t>XGBRegressor</a:t>
                       </a:r>
                       <a:endParaRPr lang="en-US" sz="1000" dirty="0"/>
                     </a:p>
@@ -6908,7 +6889,7 @@
                             <a:srgbClr val="00C9A7"/>
                           </a:solidFill>
                         </a:rPr>
-                        <a:t>0.937</a:t>
+                        <a:t>0.938</a:t>
                       </a:r>
                       <a:endParaRPr lang="en-US" sz="1000" dirty="0"/>
                     </a:p>
@@ -6969,7 +6950,7 @@
                             <a:srgbClr val="00C9A7"/>
                           </a:solidFill>
                         </a:rPr>
-                        <a:t>12.07</a:t>
+                        <a:t>12.00</a:t>
                       </a:r>
                       <a:endParaRPr lang="en-US" sz="1000" dirty="0"/>
                     </a:p>
@@ -7030,7 +7011,7 @@
                             <a:srgbClr val="00C9A7"/>
                           </a:solidFill>
                         </a:rPr>
-                        <a:t>8.18</a:t>
+                        <a:t>8.54</a:t>
                       </a:r>
                       <a:endParaRPr lang="en-US" sz="1000" dirty="0"/>
                     </a:p>
@@ -7173,7 +7154,7 @@
                             <a:srgbClr val="D8E2F5"/>
                           </a:solidFill>
                         </a:rPr>
-                        <a:t>XGBRegressor</a:t>
+                        <a:t>Extra Trees</a:t>
                       </a:r>
                       <a:endParaRPr lang="en-US" sz="1000" dirty="0"/>
                     </a:p>
@@ -7240,7 +7221,7 @@
                             <a:srgbClr val="D8E2F5"/>
                           </a:solidFill>
                         </a:rPr>
-                        <a:t>0.936</a:t>
+                        <a:t>0.937</a:t>
                       </a:r>
                       <a:endParaRPr lang="en-US" sz="1000" dirty="0"/>
                     </a:p>
@@ -7301,7 +7282,7 @@
                             <a:srgbClr val="D8E2F5"/>
                           </a:solidFill>
                         </a:rPr>
-                        <a:t>12.18</a:t>
+                        <a:t>12.07</a:t>
                       </a:r>
                       <a:endParaRPr lang="en-US" sz="1000" dirty="0"/>
                     </a:p>
@@ -7362,7 +7343,7 @@
                             <a:srgbClr val="D8E2F5"/>
                           </a:solidFill>
                         </a:rPr>
-                        <a:t>8.74</a:t>
+                        <a:t>8.18</a:t>
                       </a:r>
                       <a:endParaRPr lang="en-US" sz="1000" dirty="0"/>
                     </a:p>

</xml_diff>